<commit_message>
Gruppe 4, Gesellschafter und Geschäftsführung eintragen
Nick und Luca sind die beiden Gesellschafter (je 50 %, je 500 €
Stammkapital) und führen gemeinsam die Geschäfte. Folie 1, Folie 4,
die Notizen und die Planung sind entsprechend angepasst.

Co-Authored-By: Claude Opus 5.5 <noreply@anthropic.com>
Claude-Session: https://claude.ai/code/session_01BY9FNwv3EtsTEH4K93PUbf
</commit_message>
<xml_diff>
--- a/praesentation/LootLager_Praesentation.pptx
+++ b/praesentation/LootLager_Praesentation.pptx
@@ -110,12 +110,12 @@
   <p:extLst>
     <p:ext uri="{521415D9-36F7-43E2-AB2F-B90AF26B5E84}">
       <p14:sectionLst xmlns:p14="http://schemas.microsoft.com/office/powerpoint/2010/main">
-        <p14:section name="Start" id="{1f21e620-02d9-7667-c420-869d3341a757}">
+        <p14:section name="Start" id="{8b2633a6-3486-809e-f6cf-50b33d16ec60}">
           <p14:sldIdLst>
             <p14:sldId id="256"/>
           </p14:sldIdLst>
         </p14:section>
-        <p14:section name="Unser Unternehmen" id="{3425e527-47e1-463c-4e4e-bcd1c97bd47c}">
+        <p14:section name="Unser Unternehmen" id="{7cf94b8d-eb77-2773-e436-d1b9f7dd084e}">
           <p14:sldIdLst>
             <p14:sldId id="257"/>
             <p14:sldId id="258"/>
@@ -529,7 +529,9 @@
               <a:t>SPRECHTEXT (ca. 30 Sekunden):
 Wir sind die LootLager UG (haftungsbeschränkt). Wir verkaufen Gaming-Zubehör mit Custom Designs: Unsere Kunden bekommen ihr eigenes Design, entweder selbst hochgeladen oder von uns gestaltet. Unsere Marke heißt genauso wie die Firma: LootLager. Unser Slogan ist „Level up dein Setup.“ Als Rechtsform haben wir die UG (haftungsbeschränkt) gewählt: Wir haften nicht mit unserem Privatvermögen und brauchen kein großes Startkapital.
 NACHFRAGE „Warum die UG?“:
-Wir sind mehrere Gründer und wollen nicht mit unserem Privatvermögen haften. Für eine GmbH fehlen uns die 25.000 € Stammkapital. Die UG gibt uns die beschränkte Haftung schon ab 1 € Stammkapital.</a:t>
+Wir sind zwei Gründer und wollen nicht mit unserem Privatvermögen haften. Für eine GmbH fehlen uns die 25.000 € Stammkapital. Die UG gibt uns die beschränkte Haftung schon ab 1 € Stammkapital.
+NACHFRAGE „Wer führt die Geschäfte?“:
+Wir beide: Nick und Luca sind gemeinsam Geschäftsführer.</a:t>
             </a:r>
             <a:endParaRPr lang="en-US" dirty="0"/>
           </a:p>
@@ -797,15 +799,17 @@
             <a:r>
               <a:rPr lang="en-US" dirty="0"/>
               <a:t>WARUM DIE UG?
-Wir sind mehrere Gründer und wollen nicht mit unserem Privatvermögen haften. Für eine GmbH fehlen uns die 25.000 € Stammkapital. Die UG gibt uns die beschränkte Haftung schon ab 1 € Stammkapital.
+Wir sind zwei Gründer und wollen nicht mit unserem Privatvermögen haften. Für eine GmbH fehlen uns die 25.000 € Stammkapital. Die UG gibt uns die beschränkte Haftung schon ab 1 € Stammkapital.
 WAS HEISST HAFTUNGSBESCHRÄNKT?
 Wenn die Firma Schulden hat, haftet nur das Vermögen der Gesellschaft. Unser privates Geld ist geschützt.
 WARUM KEINE GbR ODER OHG?
 Dort haftet jeder Gesellschafter unbeschränkt mit seinem Privatvermögen, auch für die Schulden der anderen. Im Onlinehandel ist das zu riskant, z. B. bei Abmahnungen oder wenn wir auf Ware sitzen bleiben.
 WARUM KEIN EINZELUNTERNEHMEN?
-Ein Einzelunternehmen hat nur einen Inhaber, wir sind aber mehrere. Außerdem haftet der Inhaber unbeschränkt.
+Ein Einzelunternehmen hat nur einen Inhaber, wir sind aber zu zweit. Außerdem haftet der Inhaber unbeschränkt.
+WIE VIEL STAMMKAPITAL?
+1.000 €. Nick und Luca sind die Gesellschafter und zahlen je 500 € ein.
 WER FÜHRT DIE GESCHÄFTE?
-Ein Geschäftsführer, den wir Gesellschafter bestimmen. Bei uns: ________
+Wir beide: Nick und Luca sind gemeinsam Geschäftsführer. Die Geschäftsführung bestimmen die Gesellschafter, und das sind bei uns auch wir zwei.
 WIE GRÜNDET MAN EINE UG?
 Gesellschaftsvertrag beim Notar → Stammkapital einzahlen → Eintrag ins Handelsregister → Gewerbe anmelden → Finanzamt.</a:t>
             </a:r>
@@ -2116,7 +2120,7 @@
                   <a:schemeClr val="accent6"/>
                 </a:solidFill>
               </a:rPr>
-              <a:t>Gruppe ___  ·  [Eure Namen eintragen]</a:t>
+              <a:t>Gruppe 4  ·  Nick und Luca</a:t>
             </a:r>
             <a:endParaRPr lang="en-US" sz="1300" dirty="0"/>
           </a:p>
@@ -4347,7 +4351,7 @@
                   <a:schemeClr val="tx1"/>
                 </a:solidFill>
               </a:rPr>
-              <a:t>Gründung ab 1 € möglich. Wir starten mit 1.000 €.</a:t>
+              <a:t>Gründung ab 1 € möglich. Wir starten mit 1.000 €, je 500 € pro Person.</a:t>
             </a:r>
             <a:endParaRPr lang="en-US" sz="1400" dirty="0"/>
           </a:p>
@@ -4355,7 +4359,7 @@
       </p:sp>
       <p:sp>
         <p:nvSpPr>
-          <p:cNvPr id="13" name="Vorteil Alle sind Gesellschafter"/>
+          <p:cNvPr id="13" name="Vorteil Zwei Gesellschafter"/>
           <p:cNvSpPr/>
           <p:nvPr/>
         </p:nvSpPr>
@@ -4377,7 +4381,7 @@
       </p:sp>
       <p:sp>
         <p:nvSpPr>
-          <p:cNvPr id="14" name="Alle sind Gesellschafter Kreis"/>
+          <p:cNvPr id="14" name="Zwei Gesellschafter Kreis"/>
           <p:cNvSpPr/>
           <p:nvPr/>
         </p:nvSpPr>
@@ -4397,7 +4401,7 @@
       </p:sp>
       <p:pic>
         <p:nvPicPr>
-          <p:cNvPr id="15" name="Alle sind Gesellschafter Icon" descr="Alle sind Gesellschafter">    </p:cNvPr>
+          <p:cNvPr id="15" name="Zwei Gesellschafter Icon" descr="Zwei Gesellschafter">    </p:cNvPr>
           <p:cNvPicPr>
             <a:picLocks noChangeAspect="1"/>
           </p:cNvPicPr>
@@ -4421,7 +4425,7 @@
       </p:pic>
       <p:sp>
         <p:nvSpPr>
-          <p:cNvPr id="16" name="Alle sind Gesellschafter Titel"/>
+          <p:cNvPr id="16" name="Zwei Gesellschafter Titel"/>
           <p:cNvSpPr txBox="1"/>
           <p:nvPr/>
         </p:nvSpPr>
@@ -4449,7 +4453,7 @@
                   <a:schemeClr val="tx1"/>
                 </a:solidFill>
               </a:rPr>
-              <a:t>Alle sind Gesellschafter</a:t>
+              <a:t>Zwei Gesellschafter</a:t>
             </a:r>
             <a:endParaRPr lang="en-US" sz="1800" dirty="0"/>
           </a:p>
@@ -4457,7 +4461,7 @@
       </p:sp>
       <p:sp>
         <p:nvSpPr>
-          <p:cNvPr id="17" name="Alle sind Gesellschafter Text"/>
+          <p:cNvPr id="17" name="Zwei Gesellschafter Text"/>
           <p:cNvSpPr txBox="1"/>
           <p:nvPr/>
         </p:nvSpPr>
@@ -4485,7 +4489,7 @@
                   <a:schemeClr val="tx1"/>
                 </a:solidFill>
               </a:rPr>
-              <a:t>Jedes Gruppenmitglied hält den gleichen Anteil.</a:t>
+              <a:t>Nick und Luca halten je 50 % und führen gemeinsam die Geschäfte.</a:t>
             </a:r>
             <a:endParaRPr lang="en-US" sz="1400" dirty="0"/>
           </a:p>

</xml_diff>

<commit_message>
Namensprüfung und Preis-Check als fiktiv erledigt eintragen
Die Gründung ist nur ein Projekt für das Fach E-Commerce. Deshalb
nehmen wir an, dass Firmenname, Marke, Domain und Social-Media-Namen
frei sind, und die Preise aus den Preisvergleichen vom 07.10.2026
reichen. In der Planung steht jetzt, wo man bei einer echten Gründung
prüfen würde. Für die Nachfrage „Gibt es den Namen schon?“ gibt es eine
Antwort im Spickzettel und in den Notizen von Folie 3.

Co-Authored-By: Claude Opus 5.5 <noreply@anthropic.com>
Claude-Session: https://claude.ai/code/session_015ixsdrqSZWqhFMyMFQxwNp
</commit_message>
<xml_diff>
--- a/praesentation/LootLager_Praesentation.pptx
+++ b/praesentation/LootLager_Praesentation.pptx
@@ -709,13 +709,36 @@
           <a:lstStyle/>
           <a:p>
             <a:r>
-              <a:rPr lang="en-US" dirty="0"/>
-              <a:t>„Loot“ ist in Videospielen die Beute, die man als Belohnung bekommt. „Lager“ steht für unseren Shop, in dem alles für dein Gaming-Setup bereitliegt. Der Name ist kurz, passt zu unserer Zielgruppe und ist durch das doppelte L leicht zu merken.
-Logo: Die Truhe ist eine Loot-Kiste wie in Videospielen. Wer bei uns bestellt, bekommt seine Belohnung. Violett und Türkis sind typische Gaming-Farben. Das Logo haben wir mit ChatGPT erstellt.
-NACHFRAGE „Unterschied Firma und Marke?“:
-Die Firma ist der rechtliche Name unseres Unternehmens. Sie steht im Handelsregister und enthält die Rechtsform: LootLager UG (haftungsbeschränkt). Die Marke ist der Name, unter dem die Kunden unseren Shop und unsere Produkte kennen: LootLager. Bei uns heißen beide gleich, so erkennt man uns leichter wieder.</a:t>
-            </a:r>
-            <a:endParaRPr lang="en-US" dirty="0"/>
+              <a:t>„Loot“ ist in Videospielen die Beute, die man als Belohnung bekommt. „Lager“ steht für unseren Shop, in dem alles für dein Gaming-Setup bereitliegt. Der Name ist kurz, passt zu unserer Zielgruppe und ist durch das doppelte L leicht zu merken.</a:t>
+            </a:r>
+          </a:p>
+          <a:p/>
+          <a:p>
+            <a:r>
+              <a:t>Logo: Die Truhe ist eine Loot-Kiste wie in Videospielen. Wer bei uns bestellt, bekommt seine Belohnung. Violett und Türkis sind typische Gaming-Farben. Das Logo haben wir mit ChatGPT erstellt.</a:t>
+            </a:r>
+          </a:p>
+          <a:p/>
+          <a:p>
+            <a:r>
+              <a:t>NACHFRAGE „Unterschied Firma und Marke?“:</a:t>
+            </a:r>
+          </a:p>
+          <a:p>
+            <a:r>
+              <a:t>Die Firma ist der rechtliche Name unseres Unternehmens. Sie steht im Handelsregister und enthält die Rechtsform: LootLager UG (haftungsbeschränkt). Die Marke ist der Name, unter dem die Kunden unseren Shop und unsere Produkte kennen: LootLager. Bei uns heißen beide gleich, so erkennt man uns leichter wieder.</a:t>
+            </a:r>
+          </a:p>
+          <a:p/>
+          <a:p>
+            <a:r>
+              <a:t>NACHFRAGE „Gibt es den Namen schon?“:</a:t>
+            </a:r>
+          </a:p>
+          <a:p>
+            <a:r>
+              <a:t>Unsere Gründung ist fiktiv, deshalb nehmen wir an, dass der Name frei ist. Eine kurze Websuche hat keinen Shop „LootLager“ gefunden. Bei einer echten Gründung würden wir im Handelsregister nach der Firma suchen, beim DPMA nach der Marke und bei der DENIC nach der Domain lootlager.de.</a:t>
+            </a:r>
           </a:p>
         </p:txBody>
       </p:sp>

</xml_diff>

<commit_message>
Shop, Rechtstexte und Folien nach Prüfliste überarbeiten
Shop:
- Handy: Menüknopf für die Navigation, Text steht vor dem Truhenbild
- Kasse als Testbestellung mit Adresse, Zahlungsart und Knopf
  "Zahlungspflichtig bestellen" (nichts wird gesendet oder gespeichert)
- Warenkorb: Fokus bleibt nach + und - auf dem Knopf
- noindex in allen Seiten und in netlify.toml, eigene 404-Seite
- Rechtliches: Widerruf nach Produktart getrennt, Hosting-Text korrigiert
- Sechs ungenutzte Bilddateien entfernt

Präsentation:
- Folie 3 mit gekürztem Logo-Prompt, Folie 4 mit Sprechtext
- Folie 5 und 6: Ergebnis als knapp gekennzeichnet, Netlify als
  US-Anbieter beschrieben, Rechtstexte "extra besorgen"
- Folie 6 mit neuem Screenshot der Startseite, Notizen mit Live-Demo
- Folie 7 mit vollständigen Quellen, Folie 8 mit QR-Code zum Shop

PLANUNG.md: aktueller Stand oben, neue Spickzettel-Antworten.

Co-Authored-By: Claude Opus 5.5 <noreply@anthropic.com>
</commit_message>
<xml_diff>
--- a/praesentation/LootLager_Praesentation.pptx
+++ b/praesentation/LootLager_Praesentation.pptx
@@ -795,6 +795,28 @@
               <a:t>Nein, in echt ist lootlager.de schon vergeben. Das zeigt die Abfrage bei der DENIC (Stand 13.10.2026). Weil unsere Gründung fiktiv ist, tun wir so, als wäre sie frei. Online stellen können wir den Shop trotzdem: über die kostenlose Netlify-Adresse lootlager.netlify.app.</a:t>
             </a:r>
           </a:p>
+          <a:p/>
+          <a:p>
+            <a:r>
+              <a:t>NACHFRAGE „Wie habt ihr das Logo gemacht?“:</a:t>
+            </a:r>
+          </a:p>
+          <a:p>
+            <a:r>
+              <a:t>Mit ChatGPT. Unser Prompt, gekürzt: „Erstelle ein Logo für unseren Onlineshop LootLager. Symbol: eine stilisierte, leicht geöffnete Schatztruhe wie eine Loot-Kiste aus Videospielen, aus der helles Licht strahlt. Schriftzug LootLager daneben, Loot in Violett, Lager in Türkis. Stil: flaches Vektor-Design, klare Formen, Hintergrund weiß, kein weiterer Text.“ Der ganze Prompt steht in unserer Planung in Abschnitt 4.</a:t>
+            </a:r>
+          </a:p>
+          <a:p/>
+          <a:p>
+            <a:r>
+              <a:t>NACHFRAGE „Im Prompt stehen LED-Leisten und Controller-Ständer?“:</a:t>
+            </a:r>
+          </a:p>
+          <a:p>
+            <a:r>
+              <a:t>Stimmt. Das Logo war zuerst fertig, das Sortiment haben wir danach festgelegt. Das Logo zeigt nur die Truhe und kein Produkt, deshalb passt es weiterhin.</a:t>
+            </a:r>
+          </a:p>
         </p:txBody>
       </p:sp>
       <p:sp>
@@ -878,23 +900,96 @@
           <a:lstStyle/>
           <a:p>
             <a:r>
-              <a:rPr lang="en-US" dirty="0"/>
-              <a:t>WARUM DIE UG?
-Wir sind zwei Gründer und wollen nicht mit unserem Privatvermögen haften. Für eine GmbH fehlen uns die 25.000 € Stammkapital. Die UG gibt uns die beschränkte Haftung schon ab 1 € Stammkapital.
-WAS HEISST HAFTUNGSBESCHRÄNKT?
-Wenn die Firma Schulden hat, haftet nur das Vermögen der Gesellschaft. Unser privates Geld ist geschützt.
-WARUM KEINE GbR ODER OHG?
-Dort haftet jeder Gesellschafter unbeschränkt mit seinem Privatvermögen, auch für die Schulden der anderen. Im Onlinehandel ist das zu riskant, z. B. bei Abmahnungen oder wenn wir auf Ware sitzen bleiben.
-WARUM KEIN EINZELUNTERNEHMEN?
-Ein Einzelunternehmen hat nur einen Inhaber, wir sind aber zu zweit. Außerdem haftet der Inhaber unbeschränkt.
-WIE VIEL STAMMKAPITAL?
-1.000 €. Nick und Luca sind die Gesellschafter und zahlen je 500 € ein.
-WER FÜHRT DIE GESCHÄFTE?
-Wir beide: Nick und Luca sind gemeinsam Geschäftsführer. Die Geschäftsführung bestimmen die Gesellschafter, und das sind bei uns auch wir zwei.
-WIE GRÜNDET MAN EINE UG?
-Gesellschaftsvertrag beim Notar → Stammkapital einzahlen → Eintrag ins Handelsregister → Gewerbe anmelden → Finanzamt.</a:t>
-            </a:r>
-            <a:endParaRPr lang="en-US" dirty="0"/>
+              <a:t>SPRECHTEXT:</a:t>
+            </a:r>
+          </a:p>
+          <a:p>
+            <a:r>
+              <a:t>Als Rechtsform haben wir die UG (haftungsbeschränkt) gewählt. Dafür gibt es vier Gründe. Erstens: Die Haftung ist beschränkt. Bei Schulden haftet nur die Firma, nicht unser Privatvermögen. Zweitens: Wir brauchen wenig Startkapital. Eine UG kann man schon ab 1 € gründen, wir starten mit 1.000 €, jeder zahlt 500 € ein. Drittens: Die UG passt zu zwei Gründern. Wir halten je 50 % und führen die Geschäfte gemeinsam. Viertens: Wir können wachsen. Sobald das Stammkapital 25.000 € erreicht, können wir zur GmbH werden.</a:t>
+            </a:r>
+          </a:p>
+          <a:p/>
+          <a:p>
+            <a:r>
+              <a:t>Es gibt auch Nachteile: Ein Viertel vom Gewinn müssen wir jedes Jahr zurücklegen. Notar und Handelsregister kosten Geld. Und Banken und Lieferanten vertrauen einer UG weniger als einer GmbH. Eine GmbH wäre die Alternative, aber dafür fehlen uns die 25.000 € Stammkapital.</a:t>
+            </a:r>
+          </a:p>
+          <a:p/>
+          <a:p>
+            <a:r>
+              <a:t>WARUM DIE UG?</a:t>
+            </a:r>
+          </a:p>
+          <a:p>
+            <a:r>
+              <a:t>Wir sind zwei Gründer und wollen nicht mit unserem Privatvermögen haften. Für eine GmbH fehlen uns die 25.000 € Stammkapital. Die UG gibt uns die beschränkte Haftung schon ab 1 € Stammkapital.</a:t>
+            </a:r>
+          </a:p>
+          <a:p/>
+          <a:p>
+            <a:r>
+              <a:t>WAS HEISST HAFTUNGSBESCHRÄNKT?</a:t>
+            </a:r>
+          </a:p>
+          <a:p>
+            <a:r>
+              <a:t>Wenn die Firma Schulden hat, haftet nur das Vermögen der Gesellschaft. Unser privates Geld ist geschützt.</a:t>
+            </a:r>
+          </a:p>
+          <a:p/>
+          <a:p>
+            <a:r>
+              <a:t>WARUM KEINE GbR ODER OHG?</a:t>
+            </a:r>
+          </a:p>
+          <a:p>
+            <a:r>
+              <a:t>Dort haftet jeder Gesellschafter unbeschränkt mit seinem Privatvermögen, auch für die Schulden der anderen. Im Onlinehandel ist das zu riskant, z. B. bei Abmahnungen oder wenn wir auf Ware sitzen bleiben.</a:t>
+            </a:r>
+          </a:p>
+          <a:p/>
+          <a:p>
+            <a:r>
+              <a:t>WARUM KEIN EINZELUNTERNEHMEN?</a:t>
+            </a:r>
+          </a:p>
+          <a:p>
+            <a:r>
+              <a:t>Ein Einzelunternehmen hat nur einen Inhaber, wir sind aber zu zweit. Außerdem haftet der Inhaber unbeschränkt.</a:t>
+            </a:r>
+          </a:p>
+          <a:p/>
+          <a:p>
+            <a:r>
+              <a:t>WIE VIEL STAMMKAPITAL?</a:t>
+            </a:r>
+          </a:p>
+          <a:p>
+            <a:r>
+              <a:t>1.000 €. Nick und Luca sind die Gesellschafter und zahlen je 500 € ein.</a:t>
+            </a:r>
+          </a:p>
+          <a:p/>
+          <a:p>
+            <a:r>
+              <a:t>WER FÜHRT DIE GESCHÄFTE?</a:t>
+            </a:r>
+          </a:p>
+          <a:p>
+            <a:r>
+              <a:t>Wir beide: Nick und Luca sind gemeinsam Geschäftsführer. Die Geschäftsführung bestimmen die Gesellschafter, und das sind bei uns auch wir zwei.</a:t>
+            </a:r>
+          </a:p>
+          <a:p/>
+          <a:p>
+            <a:r>
+              <a:t>WIE GRÜNDET MAN EINE UG?</a:t>
+            </a:r>
+          </a:p>
+          <a:p>
+            <a:r>
+              <a:t>Gesellschaftsvertrag beim Notar → Stammkapital einzahlen → Eintrag ins Handelsregister → Gewerbe anmelden → Finanzamt.</a:t>
+            </a:r>
           </a:p>
         </p:txBody>
       </p:sp>
@@ -1065,6 +1160,28 @@
               <a:t>Die Punkte haben wir selbst vergeben. Die Preise kommen von netlify.com und aus Preisvergleichen im Internet, Stand 13.10.2026.</a:t>
             </a:r>
           </a:p>
+          <a:p/>
+          <a:p>
+            <a:r>
+              <a:t>NETLIFY BEKOMMT BEI DEN KOSTEN 10 PUNKTE. IHR BRAUCHT ABER CLAUDE CODE FÜR 21 €?</a:t>
+            </a:r>
+          </a:p>
+          <a:p>
+            <a:r>
+              <a:t>Stimmt, das Abo brauchen wir zum Bauen. Aber nur, solange wir an der Seite arbeiten. Danach können wir es kündigen, und die Seite läuft bei Netlify für 0 € weiter. Bei Shopify und Jimdo zahlen wir jeden Monat, solange es den Shop gibt.</a:t>
+            </a:r>
+          </a:p>
+          <a:p/>
+          <a:p>
+            <a:r>
+              <a:t>WIE SICHER IST DAS ERGEBNIS?</a:t>
+            </a:r>
+          </a:p>
+          <a:p>
+            <a:r>
+              <a:t>Es ist knapp: 7,65 gegen 7,45 Punkte. Das Ergebnis hängt an unserer Gewichtung. Uns sind die Kosten am wichtigsten, weil wir wenig Startkapital haben. Wäre uns die Zahlung wichtiger als die Kosten, würde Shopify gewinnen: Mit 20 % für die Kosten und 20 % für Warenkorb und Zahlung hätte Shopify 7,70 Punkte und Netlify 7,35. Deshalb ist Shopify unsere zweite Wahl, sobald wir echte Bestellungen haben.</a:t>
+            </a:r>
+          </a:p>
         </p:txBody>
       </p:sp>
       <p:sp>
@@ -1155,12 +1272,23 @@
           <a:p/>
           <a:p>
             <a:r>
+              <a:t>LIVE-DEMO (ca. 1 Minute, falls Internet und Zeit da sind):</a:t>
+            </a:r>
+          </a:p>
+          <a:p>
+            <a:r>
+              <a:t>1. Shop öffnen und zu „Eigenes Design“ gehen. 2. Produkt wählen, ein Bild hochladen, Gamertag eintippen: Die Vorschau ändert sich sofort. 3. „In den Warenkorb“ klicken und den Warenkorb öffnen. 4. „Zur Kasse“: Testdaten eintragen und auf „Zahlungspflichtig bestellen“ klicken. Ohne Internet geht es auch: im Projektordner shop/index.html doppelklicken.</a:t>
+            </a:r>
+          </a:p>
+          <a:p/>
+          <a:p>
+            <a:r>
               <a:t>HAT NETLIFY AUCH NACHTEILE?</a:t>
             </a:r>
           </a:p>
           <a:p>
             <a:r>
-              <a:t>Ja. Netlify ist kein fertiges Shopsystem. Den Warenkorb haben wir selbst gebaut, und eine echte Zahlung müssten wir noch einbauen, zum Beispiel mit PayPal oder Stripe. Die Server stehen in den USA, das müssen wir in der Datenschutzerklärung angeben. Und Rechtstexte wie AGB bekommen wir nicht mitgeliefert.</a:t>
+              <a:t>Ja. Netlify ist kein fertiges Shopsystem. Den Warenkorb haben wir selbst gebaut, und eine echte Zahlung müssten wir noch einbauen, zum Beispiel mit PayPal oder Stripe. Netlify ist ein Unternehmen aus den USA. Die Seite wird zwar über ein weltweites Netz von Servern ausgeliefert, in Europa zum Beispiel aus Frankfurt. Trotzdem können Daten in die USA gehen, das müssen wir in der Datenschutzerklärung angeben. Und Rechtstexte wie AGB bekommen wir nicht mitgeliefert. Die würden wir bei einem Anbieter wie dem Händlerbund holen und nicht selbst schreiben, weil Fehler zu Abmahnungen führen können.</a:t>
             </a:r>
           </a:p>
           <a:p/>
@@ -1171,7 +1299,7 @@
           </a:p>
           <a:p>
             <a:r>
-              <a:t>Nein. Der Shop ist eine Demo für unser Schulprojekt. Man kann Produkte in den Warenkorb legen, aber an der Kasse kommt ein Hinweis, dass es keine echten Bestellungen gibt.</a:t>
+              <a:t>Nein. Der Shop ist eine Demo für unser Schulprojekt. Man kann Produkte in den Warenkorb legen und an der Kasse eine Testbestellung durchspielen, mit Adresse und Zahlungsart. Am Ende kommt der Hinweis, dass nichts bestellt und nichts gespeichert wurde.</a:t>
             </a:r>
           </a:p>
           <a:p/>
@@ -1193,18 +1321,40 @@
           </a:p>
           <a:p>
             <a:r>
-              <a:t>Weil unsere Produkte nach Kundenwunsch bedruckt werden. Für solche individuellen Produkte gibt es kein Widerrufsrecht (§ 312g Abs. 2 Nr. 1 BGB). Darauf müssen wir in der Widerrufsbelehrung hinweisen. Deshalb zeigen wir vor dem Kauf eine Design-Vorschau.</a:t>
+              <a:t>Weil die meisten Produkte nach Kundenwunsch bedruckt werden. Für Produkte mit eigenem Motiv oder Gamertag gibt es kein Widerrufsrecht (§ 312g Abs. 2 Nr. 1 BGB). Darauf müssen wir in der Widerrufsbelehrung hinweisen. Deshalb zeigen wir vor dem Kauf eine Design-Vorschau.</a:t>
             </a:r>
           </a:p>
           <a:p/>
           <a:p>
             <a:r>
+              <a:t>UND WENN ICH EIN PRODUKT MIT EUREM DESIGN KAUFE?</a:t>
+            </a:r>
+          </a:p>
+          <a:p>
+            <a:r>
+              <a:t>Dann gilt das normale Widerrufsrecht: Man kann den Kauf 14 Tage lang ohne Grund widerrufen. Die Ausnahme gilt nur für Produkte, die extra für einen Kunden angefertigt werden.</a:t>
+            </a:r>
+          </a:p>
+          <a:p/>
+          <a:p>
+            <a:r>
               <a:t>WELCHE PFLICHTSEITEN BRAUCHT EIN SHOP?</a:t>
             </a:r>
           </a:p>
           <a:p>
             <a:r>
               <a:t>Impressum (§ 5 DDG), Datenschutzerklärung (DSGVO), AGB, Widerrufsbelehrung sowie Infos zu Versand und Zahlung. Auf unserer Seite stehen sie unten im Footer unter „Rechtliches“.</a:t>
+            </a:r>
+          </a:p>
+          <a:p/>
+          <a:p>
+            <a:r>
+              <a:t>WARUM HEISST DER KNOPF „ZAHLUNGSPFLICHTIG BESTELLEN“?</a:t>
+            </a:r>
+          </a:p>
+          <a:p>
+            <a:r>
+              <a:t>Das ist die Button-Lösung aus § 312j Abs. 3 BGB. Der letzte Knopf muss eindeutig zeigen, dass es ab jetzt Geld kostet. Direkt darüber steht der Gesamtpreis mit Mehrwertsteuer und Versand.</a:t>
             </a:r>
           </a:p>
         </p:txBody>
@@ -1372,6 +1522,12 @@
           <a:p>
             <a:r>
               <a:t>Vielen Dank fürs Zuhören! Habt ihr noch Fragen?</a:t>
+            </a:r>
+          </a:p>
+          <a:p/>
+          <a:p>
+            <a:r>
+              <a:t>Wer unseren Shop ausprobieren will: Der QR-Code führt zu lootlager.netlify.app. (Vorher prüfen, dass der Shop unter genau dieser Adresse online ist.)</a:t>
             </a:r>
           </a:p>
           <a:p/>
@@ -4914,6 +5070,50 @@
       </p:sp>
       <p:sp>
         <p:nvSpPr>
+          <p:cNvPr id="30" name="Logo Prompt"/>
+          <p:cNvSpPr txBox="1"/>
+          <p:nvPr/>
+        </p:nvSpPr>
+        <p:spPr>
+          <a:xfrm>
+            <a:off x="4846320" y="5669280"/>
+            <a:ext cx="6793992" cy="457200"/>
+          </a:xfrm>
+          <a:prstGeom prst="rect">
+            <a:avLst/>
+          </a:prstGeom>
+          <a:noFill/>
+          <a:ln/>
+        </p:spPr>
+        <p:txBody>
+          <a:bodyPr wrap="square" lIns="0" tIns="0" rIns="0" bIns="0" rtlCol="0" anchor="t"/>
+          <a:lstStyle/>
+          <a:p>
+            <a:pPr algn="l" indent="0" marL="0">
+              <a:buNone/>
+            </a:pPr>
+            <a:r>
+              <a:rPr lang="de-DE" sz="1200" b="1" dirty="0">
+                <a:solidFill>
+                  <a:schemeClr val="accent6"/>
+                </a:solidFill>
+              </a:rPr>
+              <a:t xml:space="preserve">Unser Prompt für ChatGPT (gekürzt): </a:t>
+            </a:r>
+            <a:r>
+              <a:rPr lang="de-DE" sz="1200" i="1" dirty="0">
+                <a:solidFill>
+                  <a:schemeClr val="accent6"/>
+                </a:solidFill>
+              </a:rPr>
+              <a:t>„Erstelle ein Logo für unseren Onlineshop LootLager. Symbol: eine stilisierte, leicht geöffnete Schatztruhe, aus der Licht strahlt. Stil: flaches Vektor-Design.“</a:t>
+            </a:r>
+            <a:endParaRPr lang="de-DE" sz="1200" dirty="0"/>
+          </a:p>
+        </p:txBody>
+      </p:sp>
+      <p:sp>
+        <p:nvSpPr>
           <p:cNvPr id="25" name="Slide Number Placeholder 0"/>
           <p:cNvSpPr>
             <a:spLocks noGrp="1"/>
@@ -9811,7 +10011,7 @@
         <p:spPr>
           <a:xfrm>
             <a:off x="548640" y="5870448"/>
-            <a:ext cx="9418320" cy="274320"/>
+            <a:ext cx="11091672" cy="274320"/>
           </a:xfrm>
           <a:prstGeom prst="rect">
             <a:avLst/>
@@ -9832,7 +10032,7 @@
                   <a:schemeClr val="accent6"/>
                 </a:solidFill>
               </a:rPr>
-              <a:t>Claude Code baut die Seite, stellt sie aber nicht ins Internet. Deshalb kombinieren wir: gebaut mit Claude Code, online bei Netlify.</a:t>
+              <a:t>Claude Code baut die Seite, Netlify stellt sie ins Internet. Das Ergebnis ist knapp: Wäre uns die Zahlung wichtiger als die Kosten, läge Shopify vorn.</a:t>
             </a:r>
             <a:endParaRPr lang="de-DE" sz="1100" dirty="0"/>
           </a:p>
@@ -10548,7 +10748,7 @@
                   <a:schemeClr val="tx1"/>
                 </a:solidFill>
               </a:rPr>
-              <a:t>Kein fertiges Shopsystem: Warenkorb und Zahlung bauen wir selbst ein. Die Server stehen in den USA. Rechtstexte schreiben wir selbst.</a:t>
+              <a:t>Kein fertiges Shopsystem, Warenkorb und Zahlung bauen wir selbst. US-Anbieter: Daten können in die USA gehen. Rechtstexte müssen wir extra besorgen.</a:t>
             </a:r>
             <a:endParaRPr lang="de-DE" sz="1200" dirty="0"/>
           </a:p>
@@ -12192,7 +12392,7 @@
         <p:spPr>
           <a:xfrm>
             <a:off x="548640" y="5559552"/>
-            <a:ext cx="11091672" cy="457200"/>
+            <a:ext cx="11091672" cy="548640"/>
           </a:xfrm>
           <a:prstGeom prst="rect">
             <a:avLst/>
@@ -12221,7 +12421,7 @@
                   <a:schemeClr val="accent6"/>
                 </a:solidFill>
               </a:rPr>
-              <a:t>HGB §§ 17–19, GmbHG §§ 4 und 5a, BGB § 312g · Preise: netlify.com/pricing und Preisvergleiche auf qualimero.com, trusted.de und eesel.ai (abgerufen am 13.10.2026) · Logo: ChatGPT (KI) · Bilder: Gemini (KI) · Shop: gebaut mit Claude Code (KI)</a:t>
+              <a:t>HGB §§ 17–19, GmbHG §§ 4 und 5a, BGB §§ 312g und 312j, MarkenG § 3, DDG § 5 · Domain: Abfrage bei denic.de · Preise: netlify.com/pricing und Preisvergleiche auf qualimero.com, trusted.de und eesel.ai (alles abgerufen am 13.10.2026) · Logo: ChatGPT (KI) · Bilder: Gemini (KI) · Shop: gebaut mit Claude Code (KI)</a:t>
             </a:r>
             <a:endParaRPr lang="de-DE" sz="1000" dirty="0"/>
           </a:p>
@@ -12450,7 +12650,7 @@
         </p:nvSpPr>
         <p:spPr>
           <a:xfrm>
-            <a:off x="548640" y="2103120"/>
+            <a:off x="548640" y="1280160"/>
             <a:ext cx="4754880" cy="822960"/>
           </a:xfrm>
           <a:prstGeom prst="rect">
@@ -12486,7 +12686,7 @@
         </p:nvSpPr>
         <p:spPr>
           <a:xfrm>
-            <a:off x="548640" y="3017520"/>
+            <a:off x="548640" y="2194560"/>
             <a:ext cx="4754880" cy="457200"/>
           </a:xfrm>
           <a:prstGeom prst="rect">
@@ -12522,7 +12722,7 @@
         </p:nvSpPr>
         <p:spPr>
           <a:xfrm>
-            <a:off x="548640" y="3566160"/>
+            <a:off x="548640" y="2743200"/>
             <a:ext cx="4754880" cy="365760"/>
           </a:xfrm>
           <a:prstGeom prst="rect">
@@ -12547,6 +12747,104 @@
               <a:t>„Level up dein Setup.“</a:t>
             </a:r>
             <a:endParaRPr lang="de-DE" sz="1800" dirty="0"/>
+          </a:p>
+        </p:txBody>
+      </p:sp>
+      <p:sp>
+        <p:nvSpPr>
+          <p:cNvPr id="10" name="QR Karte"/>
+          <p:cNvSpPr/>
+          <p:nvPr/>
+        </p:nvSpPr>
+        <p:spPr>
+          <a:xfrm>
+            <a:off x="548640" y="3383280"/>
+            <a:ext cx="1920240" cy="1920240"/>
+          </a:xfrm>
+          <a:prstGeom prst="roundRect">
+            <a:avLst>
+              <a:gd name="adj" fmla="val 7000"/>
+            </a:avLst>
+          </a:prstGeom>
+          <a:solidFill>
+            <a:schemeClr val="bg1"/>
+          </a:solidFill>
+          <a:ln>
+            <a:noFill/>
+          </a:ln>
+        </p:spPr>
+      </p:sp>
+      <p:pic>
+        <p:nvPicPr>
+          <p:cNvPr id="11" name="QR-Code" descr="QR-Code zum Shop: lootlager.netlify.app"/>
+          <p:cNvPicPr>
+            <a:picLocks noChangeAspect="1"/>
+          </p:cNvPicPr>
+          <p:nvPr/>
+        </p:nvPicPr>
+        <p:blipFill>
+          <a:blip r:embed="rId7"/>
+          <a:stretch>
+            <a:fillRect/>
+          </a:stretch>
+        </p:blipFill>
+        <p:spPr>
+          <a:xfrm>
+            <a:off x="640080" y="3474720"/>
+            <a:ext cx="1737360" cy="1737360"/>
+          </a:xfrm>
+          <a:prstGeom prst="rect">
+            <a:avLst/>
+          </a:prstGeom>
+        </p:spPr>
+      </p:pic>
+      <p:sp>
+        <p:nvSpPr>
+          <p:cNvPr id="12" name="QR Text"/>
+          <p:cNvSpPr txBox="1"/>
+          <p:nvPr/>
+        </p:nvSpPr>
+        <p:spPr>
+          <a:xfrm>
+            <a:off x="2697480" y="3474720"/>
+            <a:ext cx="2926080" cy="822960"/>
+          </a:xfrm>
+          <a:prstGeom prst="rect">
+            <a:avLst/>
+          </a:prstGeom>
+          <a:noFill/>
+          <a:ln/>
+        </p:spPr>
+        <p:txBody>
+          <a:bodyPr wrap="square" lIns="0" tIns="0" rIns="0" bIns="0" rtlCol="0" anchor="t"/>
+          <a:lstStyle/>
+          <a:p>
+            <a:pPr algn="l" indent="0" marL="0">
+              <a:buNone/>
+            </a:pPr>
+            <a:r>
+              <a:rPr lang="de-DE" sz="1800" b="1" dirty="0">
+                <a:solidFill>
+                  <a:schemeClr val="bg1"/>
+                </a:solidFill>
+              </a:rPr>
+              <a:t>Shop ausprobieren</a:t>
+            </a:r>
+            <a:endParaRPr lang="de-DE" sz="1800" dirty="0"/>
+          </a:p>
+          <a:p>
+            <a:pPr algn="l" indent="0" marL="0">
+              <a:buNone/>
+            </a:pPr>
+            <a:r>
+              <a:rPr lang="de-DE" sz="1400" dirty="0">
+                <a:solidFill>
+                  <a:schemeClr val="bg1"/>
+                </a:solidFill>
+              </a:rPr>
+              <a:t>lootlager.netlify.app</a:t>
+            </a:r>
+            <a:endParaRPr lang="de-DE" sz="1400" dirty="0"/>
           </a:p>
         </p:txBody>
       </p:sp>

</xml_diff>

<commit_message>
QR-Code und Shop-Link von Folie 8 entfernen
Auf der Abschlussfolie stehen nur noch Dank, Fragen, Slogan, Logo und
Gruppe. Den Satz zum QR-Code in den Sprechernotizen, die Hinweise in
PLANUNG.md und README.md sowie die nicht mehr genutzte Datei
assets/qr-shop.png entfernt.

Co-Authored-By: Claude Opus 5.5 <noreply@anthropic.com>
Claude-Session: https://claude.ai/code/session_01NdCXQfMiXV11ZEXksJerg8
</commit_message>
<xml_diff>
--- a/praesentation/LootLager_Praesentation.pptx
+++ b/praesentation/LootLager_Praesentation.pptx
@@ -1242,7 +1242,6 @@
               <a:rPr lang="en-US" dirty="0"/>
               <a:t>SPRECHTEXT:
 Vielen Dank fürs Zuhören! Habt ihr noch Fragen?
-Wer unseren Shop ausprobieren will: Der QR-Code führt zu lootlager.netlify.app. (Vorher prüfen, dass der Shop unter genau dieser Adresse online ist.)
 WOHER SIND DIE BILDER?
 Die Produktbilder, das Bild mit der Truhe auf der Startseite und dieses Bild vom Schreibtisch haben wir mit Gemini erstellt, einer KI von Google. Das Logo ist von ChatGPT. Die Prompts stehen in unserem Projekt im Ordner assets/ki-bilder.
 GIBT ES DIE PRODUKTE SCHON?
@@ -14358,124 +14357,6 @@
               <a:t>„Level up dein Setup.“</a:t>
             </a:r>
             <a:endParaRPr lang="en-US" sz="1800" dirty="0"/>
-          </a:p>
-        </p:txBody>
-      </p:sp>
-      <p:sp>
-        <p:nvSpPr>
-          <p:cNvPr id="5" name="QR-Karte"/>
-          <p:cNvSpPr/>
-          <p:nvPr/>
-        </p:nvSpPr>
-        <p:spPr>
-          <a:xfrm>
-            <a:off x="640080" y="3383280"/>
-            <a:ext cx="1965960" cy="1965960"/>
-          </a:xfrm>
-          <a:prstGeom prst="roundRect">
-            <a:avLst>
-              <a:gd name="adj" fmla="val 8372"/>
-            </a:avLst>
-          </a:prstGeom>
-          <a:solidFill>
-            <a:schemeClr val="bg1"/>
-          </a:solidFill>
-          <a:ln/>
-        </p:spPr>
-      </p:sp>
-      <p:pic>
-        <p:nvPicPr>
-          <p:cNvPr id="6" name="QR-Code" descr="QR-Code zum Shop: lootlager.netlify.app">    </p:cNvPr>
-          <p:cNvPicPr>
-            <a:picLocks noChangeAspect="1"/>
-          </p:cNvPicPr>
-          <p:nvPr/>
-        </p:nvPicPr>
-        <p:blipFill>
-          <a:blip r:embed="rId1"/>
-          <a:stretch>
-            <a:fillRect/>
-          </a:stretch>
-        </p:blipFill>
-        <p:spPr>
-          <a:xfrm>
-            <a:off x="731520" y="3474720"/>
-            <a:ext cx="1783080" cy="1783080"/>
-          </a:xfrm>
-          <a:prstGeom prst="rect">
-            <a:avLst/>
-          </a:prstGeom>
-        </p:spPr>
-      </p:pic>
-      <p:sp>
-        <p:nvSpPr>
-          <p:cNvPr id="7" name="Text 4"/>
-          <p:cNvSpPr txBox="1"/>
-          <p:nvPr/>
-        </p:nvSpPr>
-        <p:spPr>
-          <a:xfrm>
-            <a:off x="2834640" y="3931920"/>
-            <a:ext cx="3200400" cy="365760"/>
-          </a:xfrm>
-          <a:prstGeom prst="rect">
-            <a:avLst/>
-          </a:prstGeom>
-          <a:noFill/>
-          <a:ln/>
-        </p:spPr>
-        <p:txBody>
-          <a:bodyPr wrap="square" lIns="0" tIns="0" rIns="0" bIns="0" rtlCol="0" anchor="t"/>
-          <a:lstStyle/>
-          <a:p>
-            <a:pPr indent="0" marL="0">
-              <a:buNone/>
-            </a:pPr>
-            <a:r>
-              <a:rPr lang="en-US" sz="2000" b="1" dirty="0">
-                <a:solidFill>
-                  <a:schemeClr val="bg1"/>
-                </a:solidFill>
-              </a:rPr>
-              <a:t>Shop ausprobieren</a:t>
-            </a:r>
-            <a:endParaRPr lang="en-US" sz="2000" dirty="0"/>
-          </a:p>
-        </p:txBody>
-      </p:sp>
-      <p:sp>
-        <p:nvSpPr>
-          <p:cNvPr id="8" name="Text 5"/>
-          <p:cNvSpPr txBox="1"/>
-          <p:nvPr/>
-        </p:nvSpPr>
-        <p:spPr>
-          <a:xfrm>
-            <a:off x="2834640" y="4315968"/>
-            <a:ext cx="3200400" cy="320040"/>
-          </a:xfrm>
-          <a:prstGeom prst="rect">
-            <a:avLst/>
-          </a:prstGeom>
-          <a:noFill/>
-          <a:ln/>
-        </p:spPr>
-        <p:txBody>
-          <a:bodyPr wrap="square" lIns="0" tIns="0" rIns="0" bIns="0" rtlCol="0" anchor="t"/>
-          <a:lstStyle/>
-          <a:p>
-            <a:pPr indent="0" marL="0">
-              <a:buNone/>
-            </a:pPr>
-            <a:r>
-              <a:rPr lang="en-US" sz="1600" dirty="0">
-                <a:solidFill>
-                  <a:schemeClr val="accent2"/>
-                </a:solidFill>
-              </a:rPr>
-              <a:t>lootlager.netlify.app</a:t>
-            </a:r>
-            <a:endParaRPr lang="en-US" sz="1600" dirty="0"/>
           </a:p>
         </p:txBody>
       </p:sp>

</xml_diff>